<commit_message>
Tiep thu gop y: bo dau hieu gen-AI (chu HOA dot ngot, em-dash trong van xuoi, prompt ### Cau hoi/Tra loi); them trich dan phan Tong quan (hallucination, Transformer, RoBERTa, HNSW, HyDE); them ma nganh HTTT 7480104; them gioi thieu + ket luan moi chuong va 4 cau hoi nghien cuu (CHNC1-4) anh xa toi thuc nghiem
</commit_message>
<xml_diff>
--- a/report/Slide_BaoVe_RAG_DATN.pptx
+++ b/report/Slide_BaoVe_RAG_DATN.pptx
@@ -3252,7 +3252,7 @@
                 </a:solidFill>
                 <a:latin typeface="Calibri"/>
               </a:rPr>
-              <a:t>Đồ án tốt nghiệp — Khoa Công nghệ thông tin, Đại học Thủy lợi</a:t>
+              <a:t>Đồ án tốt nghiệp, Khoa Công nghệ thông tin, Đại học Thủy lợi</a:t>
             </a:r>
           </a:p>
         </p:txBody>
@@ -4332,7 +4332,7 @@
                 </a:solidFill>
                 <a:latin typeface="Calibri"/>
               </a:rPr>
-              <a:t>Báo cáo đầy đủ cả các hướng KHÔNG thành công, kèm phân tích nguyên nhân:</a:t>
+              <a:t>Báo cáo đầy đủ cả các hướng không thành công, kèm phân tích nguyên nhân:</a:t>
             </a:r>
           </a:p>
         </p:txBody>
@@ -4716,7 +4716,7 @@
                 </a:solidFill>
                 <a:latin typeface="Calibri"/>
               </a:rPr>
-              <a:t>Sai LOẠI dữ liệu → quên thảm họa, giảm mạnh.</a:t>
+              <a:t>Sai loại dữ liệu → quên thảm họa, giảm mạnh.</a:t>
             </a:r>
           </a:p>
         </p:txBody>
@@ -6394,7 +6394,7 @@
                 </a:solidFill>
                 <a:latin typeface="Calibri"/>
               </a:rPr>
-              <a:t>Truy xuất các đoạn văn bản đáng tin cậy → mô hình sinh trả lời DỰA TRÊN nguồn và trích dẫn → giảm bịa đặt, kiểm chứng được, cập nhật dễ.</a:t>
+              <a:t>Truy xuất các đoạn văn bản đáng tin cậy → mô hình sinh trả lời dựa trên nguồn và trích dẫn → giảm bịa đặt, kiểm chứng được, cập nhật dễ.</a:t>
             </a:r>
           </a:p>
         </p:txBody>
@@ -7850,7 +7850,7 @@
                 </a:solidFill>
                 <a:latin typeface="Calibri"/>
               </a:rPr>
-              <a:t>Khớp phân phối huấn luyện PhoBERT — đòn bẩy mạnh nhất (+0,10 Hit@1).</a:t>
+              <a:t>Khớp phân phối huấn luyện PhoBERT, đòn bẩy mạnh nhất (+0,10 Hit@1).</a:t>
             </a:r>
           </a:p>
         </p:txBody>
@@ -9585,7 +9585,7 @@
                 </a:solidFill>
                 <a:latin typeface="Calibri"/>
               </a:rPr>
-              <a:t>Người dân hỏi bằng ngôn ngữ ĐỜI THƯỜNG, không dùng thuật ngữ pháp lý:</a:t>
+              <a:t>Người dân hỏi bằng ngôn ngữ đời thường, không dùng thuật ngữ pháp lý:</a:t>
             </a:r>
           </a:p>
           <a:p>

</xml_diff>